<commit_message>
Aggiornata relazione, rimossi Dockerfile e backlog
</commit_message>
<xml_diff>
--- a/relazione_esame/Relazione_VolleyLeague.pptx
+++ b/relazione_esame/Relazione_VolleyLeague.pptx
@@ -3400,7 +3400,7 @@
                 </a:solidFill>
                 <a:latin typeface="Calibri"/>
               </a:rPr>
-              <a:t>Nome Cognome</a:t>
+              <a:t>Niccolò Gardellini</a:t>
             </a:r>
           </a:p>
           <a:p>
@@ -3416,7 +3416,7 @@
                 </a:solidFill>
                 <a:latin typeface="Calibri"/>
               </a:rPr>
-              <a:t>Matricola 000000</a:t>
+              <a:t>Matricola 209464</a:t>
             </a:r>
           </a:p>
           <a:p>
@@ -3768,7 +3768,7 @@
                 </a:solidFill>
                 <a:latin typeface="Calibri"/>
               </a:rPr>
-              <a:t>Volley League · Nome Cognome · Ingegneria del Software · UniFE · A.A. 2025/26</a:t>
+              <a:t>Volley League · Niccolò Gardellini · Ingegneria del Software · UniFE · A.A. 2025/26</a:t>
             </a:r>
           </a:p>
         </p:txBody>
@@ -3975,7 +3975,7 @@
                 </a:solidFill>
                 <a:latin typeface="Calibri"/>
               </a:rPr>
-              <a:t>•  Stima in SP con pivot CRUD = 2 abbastanza precisa (scarto &lt; 10%)</a:t>
+              <a:t>•  Il riferimento CRUD = 2 SP ha reso semplice dividere e stimare il lavoro</a:t>
             </a:r>
           </a:p>
           <a:p>
@@ -4207,7 +4207,7 @@
                 </a:solidFill>
                 <a:latin typeface="Calibri"/>
               </a:rPr>
-              <a:t>•  Ricoprire tutti i ruoli Scrum da soli richiede disciplina nel log</a:t>
+              <a:t>•  Gestire da solo analisi, sviluppo e test richiede organizzazione</a:t>
             </a:r>
           </a:p>
         </p:txBody>
@@ -4869,7 +4869,7 @@
                 </a:solidFill>
                 <a:latin typeface="Calibri"/>
               </a:rPr>
-              <a:t>Progetto svolto in autonomia: tutti i ruoli Scrum ricoperti dallo stesso studente, con contratto da 30 SP</a:t>
+              <a:t>Progetto individuale: tutte le attività sono state svolte dallo stesso studente</a:t>
             </a:r>
           </a:p>
         </p:txBody>
@@ -4908,7 +4908,7 @@
                 </a:solidFill>
                 <a:latin typeface="Calibri"/>
               </a:rPr>
-              <a:t>Volley League · Nome Cognome · Ingegneria del Software · UniFE · A.A. 2025/26</a:t>
+              <a:t>Volley League · Niccolò Gardellini · Ingegneria del Software · UniFE · A.A. 2025/26</a:t>
             </a:r>
           </a:p>
         </p:txBody>
@@ -5076,7 +5076,7 @@
                 </a:solidFill>
                 <a:latin typeface="Calibri"/>
               </a:rPr>
-              <a:t>Product Owner</a:t>
+              <a:t>Analisi</a:t>
             </a:r>
           </a:p>
         </p:txBody>
@@ -5115,7 +5115,7 @@
                 </a:solidFill>
                 <a:latin typeface="Calibri"/>
               </a:rPr>
-              <a:t>Definisce visione, backlog e criteri di accettazione delle 3 macro-funzionalità</a:t>
+              <a:t>Requisiti, ruoli utente e regole di gioco; disegno funzionale su Miro</a:t>
             </a:r>
           </a:p>
         </p:txBody>
@@ -5244,7 +5244,7 @@
                 </a:solidFill>
                 <a:latin typeface="Calibri"/>
               </a:rPr>
-              <a:t>Scrum Master</a:t>
+              <a:t>Pianificazione</a:t>
             </a:r>
           </a:p>
         </p:txBody>
@@ -5283,7 +5283,7 @@
                 </a:solidFill>
                 <a:latin typeface="Calibri"/>
               </a:rPr>
-              <a:t>Pianifica 3 sprint, conduce le cerimonie e aggiorna burndown e board Trello</a:t>
+              <a:t>Scomposizione delle 3 macro-funzionalità in task FE/BE/DB su Trello e stima in SP</a:t>
             </a:r>
           </a:p>
         </p:txBody>
@@ -5412,7 +5412,7 @@
                 </a:solidFill>
                 <a:latin typeface="Calibri"/>
               </a:rPr>
-              <a:t>Sviluppatore DB</a:t>
+              <a:t>Sviluppo DB</a:t>
             </a:r>
           </a:p>
         </p:txBody>
@@ -5580,7 +5580,7 @@
                 </a:solidFill>
                 <a:latin typeface="Calibri"/>
               </a:rPr>
-              <a:t>Sviluppatore BE</a:t>
+              <a:t>Sviluppo backend</a:t>
             </a:r>
           </a:p>
         </p:txBody>
@@ -5619,7 +5619,7 @@
                 </a:solidFill>
                 <a:latin typeface="Calibri"/>
               </a:rPr>
-              <a:t>API REST Spring Boot, sicurezza JWT/RBAC, pattern State/Strategy/Factory</a:t>
+              <a:t>API REST Spring Boot, sicurezza JWT, pattern State/Strategy/Factory</a:t>
             </a:r>
           </a:p>
         </p:txBody>
@@ -5748,7 +5748,7 @@
                 </a:solidFill>
                 <a:latin typeface="Calibri"/>
               </a:rPr>
-              <a:t>Sviluppatore FE</a:t>
+              <a:t>Sviluppo frontend</a:t>
             </a:r>
           </a:p>
         </p:txBody>
@@ -5787,7 +5787,7 @@
                 </a:solidFill>
                 <a:latin typeface="Calibri"/>
               </a:rPr>
-              <a:t>SPA Angular Material responsive, guard per ruolo, validazione dei form</a:t>
+              <a:t>Interfaccia Angular Material responsive, accesso per ruolo, validazione dei form</a:t>
             </a:r>
           </a:p>
         </p:txBody>
@@ -5916,7 +5916,7 @@
                 </a:solidFill>
                 <a:latin typeface="Calibri"/>
               </a:rPr>
-              <a:t>Tester</a:t>
+              <a:t>Test e documentazione</a:t>
             </a:r>
           </a:p>
         </p:txBody>
@@ -5955,7 +5955,7 @@
                 </a:solidFill>
                 <a:latin typeface="Calibri"/>
               </a:rPr>
-              <a:t>94 test JUnit 5 / Mockito / MockMvc, prove end-to-end sui 4 ruoli</a:t>
+              <a:t>Test JUnit / Mockito / MockMvc, prove nel browser, relazione e video</a:t>
             </a:r>
           </a:p>
         </p:txBody>
@@ -6672,13 +6672,13 @@
                 </a:solidFill>
                 <a:latin typeface="Calibri"/>
               </a:rPr>
-              <a:t>Stima con sequenza di Fibonacci (1, 2, 3, 5, 8…)</a:t>
+              <a:t>Stima degli story point</a:t>
             </a:r>
           </a:p>
           <a:p>
             <a:pPr algn="l">
               <a:spcAft>
-                <a:spcPts val="1000"/>
+                <a:spcPts val="400"/>
               </a:spcAft>
             </a:pPr>
             <a:r>
@@ -6688,39 +6688,7 @@
                 </a:solidFill>
                 <a:latin typeface="Calibri"/>
               </a:rPr>
-              <a:t>Pivot: una CRUD completa = 2 SP. Task con logica di dominio non banale (validazione referto, calendario Berger, sicurezza JWT) stimati 3 SP.</a:t>
-            </a:r>
-          </a:p>
-          <a:p>
-            <a:pPr algn="l">
-              <a:spcAft>
-                <a:spcPts val="300"/>
-              </a:spcAft>
-            </a:pPr>
-            <a:r>
-              <a:rPr sz="1300" b="1">
-                <a:solidFill>
-                  <a:srgbClr val="1F4FD1"/>
-                </a:solidFill>
-                <a:latin typeface="Calibri"/>
-              </a:rPr>
-              <a:t>Nessuna dipendenza esterna</a:t>
-            </a:r>
-          </a:p>
-          <a:p>
-            <a:pPr algn="l">
-              <a:spcAft>
-                <a:spcPts val="400"/>
-              </a:spcAft>
-            </a:pPr>
-            <a:r>
-              <a:rPr sz="1200" b="0">
-                <a:solidFill>
-                  <a:srgbClr val="1A2033"/>
-                </a:solidFill>
-                <a:latin typeface="Calibri"/>
-              </a:rPr>
-              <a:t>Lavorando da solo, la Definition of Done di ogni card include codice commentato, test verdi e verifica manuale nel browser su desktop e mobile.</a:t>
+              <a:t>Scala di Fibonacci con riferimento CRUD = 2 SP: 2 SP per le operazioni CRUD, 3 SP per i task con logica più complessa (validazione referto, calendario, sicurezza JWT).</a:t>
             </a:r>
           </a:p>
         </p:txBody>
@@ -6904,7 +6872,7 @@
                 </a:solidFill>
                 <a:latin typeface="Calibri"/>
               </a:rPr>
-              <a:t>Evidenze delle cerimonie Scrum</a:t>
+              <a:t>Evidenze delle cerimonie</a:t>
             </a:r>
           </a:p>
         </p:txBody>
@@ -6943,7 +6911,7 @@
                 </a:solidFill>
                 <a:latin typeface="Calibri"/>
               </a:rPr>
-              <a:t>3 sprint da 5 giorni lavorativi · cerimonie svolte e annotate anche in forma individuale</a:t>
+              <a:t>Cerimonie svolte in forma individuale, scandite dal completamento delle 3 macro-funzionalità</a:t>
             </a:r>
           </a:p>
         </p:txBody>
@@ -6982,7 +6950,7 @@
                 </a:solidFill>
                 <a:latin typeface="Calibri"/>
               </a:rPr>
-              <a:t>Volley League · Nome Cognome · Ingegneria del Software · UniFE · A.A. 2025/26</a:t>
+              <a:t>Volley League · Niccolò Gardellini · Ingegneria del Software · UniFE · A.A. 2025/26</a:t>
             </a:r>
           </a:p>
         </p:txBody>
@@ -7035,7 +7003,7 @@
         <p:spPr>
           <a:xfrm>
             <a:off x="411480" y="1188720"/>
-            <a:ext cx="5120640" cy="1143000"/>
+            <a:ext cx="5577840" cy="1280160"/>
           </a:xfrm>
           <a:prstGeom prst="roundRect">
             <a:avLst>
@@ -7074,14 +7042,58 @@
       </p:sp>
       <p:sp>
         <p:nvSpPr>
-          <p:cNvPr id="10" name="TextBox 9"/>
+          <p:cNvPr id="10" name="Rectangle 9"/>
+          <p:cNvSpPr/>
+          <p:nvPr/>
+        </p:nvSpPr>
+        <p:spPr>
+          <a:xfrm>
+            <a:off x="411480" y="1188720"/>
+            <a:ext cx="82296" cy="1280160"/>
+          </a:xfrm>
+          <a:prstGeom prst="rect">
+            <a:avLst/>
+          </a:prstGeom>
+          <a:solidFill>
+            <a:srgbClr val="FF9D2E"/>
+          </a:solidFill>
+          <a:ln>
+            <a:noFill/>
+          </a:ln>
+          <a:effectLst/>
+        </p:spPr>
+        <p:style>
+          <a:lnRef idx="1">
+            <a:schemeClr val="accent1"/>
+          </a:lnRef>
+          <a:fillRef idx="3">
+            <a:schemeClr val="accent1"/>
+          </a:fillRef>
+          <a:effectRef idx="2">
+            <a:schemeClr val="accent1"/>
+          </a:effectRef>
+          <a:fontRef idx="minor">
+            <a:schemeClr val="lt1"/>
+          </a:fontRef>
+        </p:style>
+        <p:txBody>
+          <a:bodyPr rtlCol="0" anchor="ctr"/>
+          <a:lstStyle/>
+          <a:p>
+            <a:pPr algn="ctr"/>
+          </a:p>
+        </p:txBody>
+      </p:sp>
+      <p:sp>
+        <p:nvSpPr>
+          <p:cNvPr id="11" name="TextBox 10"/>
           <p:cNvSpPr txBox="1"/>
           <p:nvPr/>
         </p:nvSpPr>
         <p:spPr>
           <a:xfrm>
-            <a:off x="594360" y="1280160"/>
-            <a:ext cx="4846320" cy="365760"/>
+            <a:off x="640080" y="1298448"/>
+            <a:ext cx="5212080" cy="365760"/>
           </a:xfrm>
           <a:prstGeom prst="rect">
             <a:avLst/>
@@ -7106,21 +7118,21 @@
                 </a:solidFill>
                 <a:latin typeface="Calibri"/>
               </a:rPr>
-              <a:t>Sprint planning</a:t>
-            </a:r>
-          </a:p>
-        </p:txBody>
-      </p:sp>
-      <p:sp>
-        <p:nvSpPr>
-          <p:cNvPr id="11" name="TextBox 10"/>
+              <a:t>Planning</a:t>
+            </a:r>
+          </a:p>
+        </p:txBody>
+      </p:sp>
+      <p:sp>
+        <p:nvSpPr>
+          <p:cNvPr id="12" name="TextBox 11"/>
           <p:cNvSpPr txBox="1"/>
           <p:nvPr/>
         </p:nvSpPr>
         <p:spPr>
           <a:xfrm>
-            <a:off x="594360" y="1627632"/>
-            <a:ext cx="4846320" cy="731520"/>
+            <a:off x="640080" y="1691640"/>
+            <a:ext cx="5212080" cy="731520"/>
           </a:xfrm>
           <a:prstGeom prst="rect">
             <a:avLst/>
@@ -7139,27 +7151,27 @@
               </a:spcAft>
             </a:pPr>
             <a:r>
-              <a:rPr sz="1100" b="0">
+              <a:rPr sz="1200" b="0">
                 <a:solidFill>
                   <a:srgbClr val="1A2033"/>
                 </a:solidFill>
                 <a:latin typeface="Calibri"/>
               </a:rPr>
-              <a:t>Ad ogni inizio sprint: scelta delle card dal backlog Trello, stima in SP, obiettivo di sprint scritto nella descrizione della lista.</a:t>
-            </a:r>
-          </a:p>
-        </p:txBody>
-      </p:sp>
-      <p:sp>
-        <p:nvSpPr>
-          <p:cNvPr id="12" name="Rounded Rectangle 11"/>
+              <a:t>All'avvio: scomposizione delle macro-funzionalità da Miro in task su Trello, stima in SP e ordine di lavoro MF1 → MF2 → MF3.</a:t>
+            </a:r>
+          </a:p>
+        </p:txBody>
+      </p:sp>
+      <p:sp>
+        <p:nvSpPr>
+          <p:cNvPr id="13" name="Rounded Rectangle 12"/>
           <p:cNvSpPr/>
           <p:nvPr/>
         </p:nvSpPr>
         <p:spPr>
           <a:xfrm>
-            <a:off x="411480" y="2450591"/>
-            <a:ext cx="5120640" cy="1143000"/>
+            <a:off x="6126480" y="1188720"/>
+            <a:ext cx="5577840" cy="1280160"/>
           </a:xfrm>
           <a:prstGeom prst="roundRect">
             <a:avLst>
@@ -7198,14 +7210,58 @@
       </p:sp>
       <p:sp>
         <p:nvSpPr>
-          <p:cNvPr id="13" name="TextBox 12"/>
+          <p:cNvPr id="14" name="Rectangle 13"/>
+          <p:cNvSpPr/>
+          <p:nvPr/>
+        </p:nvSpPr>
+        <p:spPr>
+          <a:xfrm>
+            <a:off x="6126480" y="1188720"/>
+            <a:ext cx="82296" cy="1280160"/>
+          </a:xfrm>
+          <a:prstGeom prst="rect">
+            <a:avLst/>
+          </a:prstGeom>
+          <a:solidFill>
+            <a:srgbClr val="FF9D2E"/>
+          </a:solidFill>
+          <a:ln>
+            <a:noFill/>
+          </a:ln>
+          <a:effectLst/>
+        </p:spPr>
+        <p:style>
+          <a:lnRef idx="1">
+            <a:schemeClr val="accent1"/>
+          </a:lnRef>
+          <a:fillRef idx="3">
+            <a:schemeClr val="accent1"/>
+          </a:fillRef>
+          <a:effectRef idx="2">
+            <a:schemeClr val="accent1"/>
+          </a:effectRef>
+          <a:fontRef idx="minor">
+            <a:schemeClr val="lt1"/>
+          </a:fontRef>
+        </p:style>
+        <p:txBody>
+          <a:bodyPr rtlCol="0" anchor="ctr"/>
+          <a:lstStyle/>
+          <a:p>
+            <a:pPr algn="ctr"/>
+          </a:p>
+        </p:txBody>
+      </p:sp>
+      <p:sp>
+        <p:nvSpPr>
+          <p:cNvPr id="15" name="TextBox 14"/>
           <p:cNvSpPr txBox="1"/>
           <p:nvPr/>
         </p:nvSpPr>
         <p:spPr>
           <a:xfrm>
-            <a:off x="594360" y="2542032"/>
-            <a:ext cx="4846320" cy="365760"/>
+            <a:off x="6355080" y="1298448"/>
+            <a:ext cx="5212080" cy="365760"/>
           </a:xfrm>
           <a:prstGeom prst="rect">
             <a:avLst/>
@@ -7230,21 +7286,21 @@
                 </a:solidFill>
                 <a:latin typeface="Calibri"/>
               </a:rPr>
-              <a:t>Daily (log)</a:t>
-            </a:r>
-          </a:p>
-        </p:txBody>
-      </p:sp>
-      <p:sp>
-        <p:nvSpPr>
-          <p:cNvPr id="14" name="TextBox 13"/>
+              <a:t>Punto quotidiano</a:t>
+            </a:r>
+          </a:p>
+        </p:txBody>
+      </p:sp>
+      <p:sp>
+        <p:nvSpPr>
+          <p:cNvPr id="16" name="TextBox 15"/>
           <p:cNvSpPr txBox="1"/>
           <p:nvPr/>
         </p:nvSpPr>
         <p:spPr>
           <a:xfrm>
-            <a:off x="594360" y="2889503"/>
-            <a:ext cx="4846320" cy="731520"/>
+            <a:off x="6355080" y="1691640"/>
+            <a:ext cx="5212080" cy="731520"/>
           </a:xfrm>
           <a:prstGeom prst="rect">
             <a:avLst/>
@@ -7263,27 +7319,27 @@
               </a:spcAft>
             </a:pPr>
             <a:r>
-              <a:rPr sz="1100" b="0">
+              <a:rPr sz="1200" b="0">
                 <a:solidFill>
                   <a:srgbClr val="1A2033"/>
                 </a:solidFill>
                 <a:latin typeface="Calibri"/>
               </a:rPr>
-              <a:t>Nota giornaliera di 3 righe su Trello: fatto ieri · farò oggi · impedimenti (es. vincolo provincia arbitri, rollback referto).</a:t>
-            </a:r>
-          </a:p>
-        </p:txBody>
-      </p:sp>
-      <p:sp>
-        <p:nvSpPr>
-          <p:cNvPr id="15" name="Rounded Rectangle 14"/>
+              <a:t>Breve verifica giornaliera: cosa è stato fatto, cosa resta, eventuali blocchi (es. vincolo provincia arbitri, rollback referto).</a:t>
+            </a:r>
+          </a:p>
+        </p:txBody>
+      </p:sp>
+      <p:sp>
+        <p:nvSpPr>
+          <p:cNvPr id="17" name="Rounded Rectangle 16"/>
           <p:cNvSpPr/>
           <p:nvPr/>
         </p:nvSpPr>
         <p:spPr>
           <a:xfrm>
-            <a:off x="411480" y="3712463"/>
-            <a:ext cx="5120640" cy="1143000"/>
+            <a:off x="411480" y="2606040"/>
+            <a:ext cx="5577840" cy="1280160"/>
           </a:xfrm>
           <a:prstGeom prst="roundRect">
             <a:avLst>
@@ -7322,14 +7378,58 @@
       </p:sp>
       <p:sp>
         <p:nvSpPr>
-          <p:cNvPr id="16" name="TextBox 15"/>
+          <p:cNvPr id="18" name="Rectangle 17"/>
+          <p:cNvSpPr/>
+          <p:nvPr/>
+        </p:nvSpPr>
+        <p:spPr>
+          <a:xfrm>
+            <a:off x="411480" y="2606040"/>
+            <a:ext cx="82296" cy="1280160"/>
+          </a:xfrm>
+          <a:prstGeom prst="rect">
+            <a:avLst/>
+          </a:prstGeom>
+          <a:solidFill>
+            <a:srgbClr val="FF9D2E"/>
+          </a:solidFill>
+          <a:ln>
+            <a:noFill/>
+          </a:ln>
+          <a:effectLst/>
+        </p:spPr>
+        <p:style>
+          <a:lnRef idx="1">
+            <a:schemeClr val="accent1"/>
+          </a:lnRef>
+          <a:fillRef idx="3">
+            <a:schemeClr val="accent1"/>
+          </a:fillRef>
+          <a:effectRef idx="2">
+            <a:schemeClr val="accent1"/>
+          </a:effectRef>
+          <a:fontRef idx="minor">
+            <a:schemeClr val="lt1"/>
+          </a:fontRef>
+        </p:style>
+        <p:txBody>
+          <a:bodyPr rtlCol="0" anchor="ctr"/>
+          <a:lstStyle/>
+          <a:p>
+            <a:pPr algn="ctr"/>
+          </a:p>
+        </p:txBody>
+      </p:sp>
+      <p:sp>
+        <p:nvSpPr>
+          <p:cNvPr id="19" name="TextBox 18"/>
           <p:cNvSpPr txBox="1"/>
           <p:nvPr/>
         </p:nvSpPr>
         <p:spPr>
           <a:xfrm>
-            <a:off x="594360" y="3803903"/>
-            <a:ext cx="4846320" cy="365760"/>
+            <a:off x="640080" y="2715768"/>
+            <a:ext cx="5212080" cy="365760"/>
           </a:xfrm>
           <a:prstGeom prst="rect">
             <a:avLst/>
@@ -7354,21 +7454,21 @@
                 </a:solidFill>
                 <a:latin typeface="Calibri"/>
               </a:rPr>
-              <a:t>Sprint review</a:t>
-            </a:r>
-          </a:p>
-        </p:txBody>
-      </p:sp>
-      <p:sp>
-        <p:nvSpPr>
-          <p:cNvPr id="17" name="TextBox 16"/>
+              <a:t>Review</a:t>
+            </a:r>
+          </a:p>
+        </p:txBody>
+      </p:sp>
+      <p:sp>
+        <p:nvSpPr>
+          <p:cNvPr id="20" name="TextBox 19"/>
           <p:cNvSpPr txBox="1"/>
           <p:nvPr/>
         </p:nvSpPr>
         <p:spPr>
           <a:xfrm>
-            <a:off x="594360" y="4151375"/>
-            <a:ext cx="4846320" cy="731520"/>
+            <a:off x="640080" y="3108960"/>
+            <a:ext cx="5212080" cy="731520"/>
           </a:xfrm>
           <a:prstGeom prst="rect">
             <a:avLst/>
@@ -7387,27 +7487,27 @@
               </a:spcAft>
             </a:pPr>
             <a:r>
-              <a:rPr sz="1100" b="0">
+              <a:rPr sz="1200" b="0">
                 <a:solidFill>
                   <a:srgbClr val="1A2033"/>
                 </a:solidFill>
                 <a:latin typeface="Calibri"/>
               </a:rPr>
-              <a:t>Demo del flusso completato nel browser: S1 calendario + designazioni, S2 rosa + lista gara, S3 referto → omologa → classifica.</a:t>
-            </a:r>
-          </a:p>
-        </p:txBody>
-      </p:sp>
-      <p:sp>
-        <p:nvSpPr>
-          <p:cNvPr id="18" name="Rounded Rectangle 17"/>
+              <a:t>Al termine di ogni macro-funzionalità: prova completa del flusso nel browser con gli account dei ruoli coinvolti.</a:t>
+            </a:r>
+          </a:p>
+        </p:txBody>
+      </p:sp>
+      <p:sp>
+        <p:nvSpPr>
+          <p:cNvPr id="21" name="Rounded Rectangle 20"/>
           <p:cNvSpPr/>
           <p:nvPr/>
         </p:nvSpPr>
         <p:spPr>
           <a:xfrm>
-            <a:off x="411480" y="4974336"/>
-            <a:ext cx="5120640" cy="1143000"/>
+            <a:off x="6126480" y="2606040"/>
+            <a:ext cx="5577840" cy="1280160"/>
           </a:xfrm>
           <a:prstGeom prst="roundRect">
             <a:avLst>
@@ -7446,14 +7546,58 @@
       </p:sp>
       <p:sp>
         <p:nvSpPr>
-          <p:cNvPr id="19" name="TextBox 18"/>
+          <p:cNvPr id="22" name="Rectangle 21"/>
+          <p:cNvSpPr/>
+          <p:nvPr/>
+        </p:nvSpPr>
+        <p:spPr>
+          <a:xfrm>
+            <a:off x="6126480" y="2606040"/>
+            <a:ext cx="82296" cy="1280160"/>
+          </a:xfrm>
+          <a:prstGeom prst="rect">
+            <a:avLst/>
+          </a:prstGeom>
+          <a:solidFill>
+            <a:srgbClr val="FF9D2E"/>
+          </a:solidFill>
+          <a:ln>
+            <a:noFill/>
+          </a:ln>
+          <a:effectLst/>
+        </p:spPr>
+        <p:style>
+          <a:lnRef idx="1">
+            <a:schemeClr val="accent1"/>
+          </a:lnRef>
+          <a:fillRef idx="3">
+            <a:schemeClr val="accent1"/>
+          </a:fillRef>
+          <a:effectRef idx="2">
+            <a:schemeClr val="accent1"/>
+          </a:effectRef>
+          <a:fontRef idx="minor">
+            <a:schemeClr val="lt1"/>
+          </a:fontRef>
+        </p:style>
+        <p:txBody>
+          <a:bodyPr rtlCol="0" anchor="ctr"/>
+          <a:lstStyle/>
+          <a:p>
+            <a:pPr algn="ctr"/>
+          </a:p>
+        </p:txBody>
+      </p:sp>
+      <p:sp>
+        <p:nvSpPr>
+          <p:cNvPr id="23" name="TextBox 22"/>
           <p:cNvSpPr txBox="1"/>
           <p:nvPr/>
         </p:nvSpPr>
         <p:spPr>
           <a:xfrm>
-            <a:off x="594360" y="5065775"/>
-            <a:ext cx="4846320" cy="365760"/>
+            <a:off x="6355080" y="2715768"/>
+            <a:ext cx="5212080" cy="365760"/>
           </a:xfrm>
           <a:prstGeom prst="rect">
             <a:avLst/>
@@ -7485,14 +7629,14 @@
       </p:sp>
       <p:sp>
         <p:nvSpPr>
-          <p:cNvPr id="20" name="TextBox 19"/>
+          <p:cNvPr id="24" name="TextBox 23"/>
           <p:cNvSpPr txBox="1"/>
           <p:nvPr/>
         </p:nvSpPr>
         <p:spPr>
           <a:xfrm>
-            <a:off x="594360" y="5413248"/>
-            <a:ext cx="4846320" cy="731520"/>
+            <a:off x="6355080" y="3108960"/>
+            <a:ext cx="5212080" cy="731520"/>
           </a:xfrm>
           <a:prstGeom prst="rect">
             <a:avLst/>
@@ -7511,51 +7655,27 @@
               </a:spcAft>
             </a:pPr>
             <a:r>
-              <a:rPr sz="1100" b="0">
+              <a:rPr sz="1200" b="0">
                 <a:solidFill>
                   <a:srgbClr val="1A2033"/>
                 </a:solidFill>
                 <a:latin typeface="Calibri"/>
               </a:rPr>
-              <a:t>Start/Stop/Continue: es. 'scrivere prima i test del validatore set' (S2), 'tenere il seed demo allineato' (S3).</a:t>
-            </a:r>
-          </a:p>
-        </p:txBody>
-      </p:sp>
-      <p:pic>
-        <p:nvPicPr>
-          <p:cNvPr id="21" name="Picture 20" descr="burndown.png"/>
-          <p:cNvPicPr>
-            <a:picLocks noChangeAspect="1"/>
-          </p:cNvPicPr>
-          <p:nvPr/>
-        </p:nvPicPr>
-        <p:blipFill>
-          <a:blip r:embed="rId2"/>
-          <a:stretch>
-            <a:fillRect/>
-          </a:stretch>
-        </p:blipFill>
-        <p:spPr>
-          <a:xfrm>
-            <a:off x="5806440" y="1188720"/>
-            <a:ext cx="5989320" cy="3284466"/>
-          </a:xfrm>
-          <a:prstGeom prst="rect">
-            <a:avLst/>
-          </a:prstGeom>
-        </p:spPr>
-      </p:pic>
-      <p:sp>
-        <p:nvSpPr>
-          <p:cNvPr id="22" name="TextBox 21"/>
+              <a:t>A fine progetto: cosa ha funzionato, difficoltà e cosa migliorare (riportato nella slide Feedback).</a:t>
+            </a:r>
+          </a:p>
+        </p:txBody>
+      </p:sp>
+      <p:sp>
+        <p:nvSpPr>
+          <p:cNvPr id="25" name="TextBox 24"/>
           <p:cNvSpPr txBox="1"/>
           <p:nvPr/>
         </p:nvSpPr>
         <p:spPr>
           <a:xfrm>
-            <a:off x="5806440" y="4526280"/>
-            <a:ext cx="5989320" cy="274320"/>
+            <a:off x="411480" y="4114800"/>
+            <a:ext cx="11338560" cy="365760"/>
           </a:xfrm>
           <a:prstGeom prst="rect">
             <a:avLst/>
@@ -7568,34 +7688,34 @@
           </a:bodyPr>
           <a:lstStyle/>
           <a:p>
-            <a:pPr algn="ctr">
+            <a:pPr algn="l">
               <a:spcAft>
                 <a:spcPts val="400"/>
               </a:spcAft>
             </a:pPr>
             <a:r>
-              <a:rPr sz="1000" b="0">
-                <a:solidFill>
-                  <a:srgbClr val="5A6378"/>
-                </a:solidFill>
-                <a:latin typeface="Calibri"/>
-              </a:rPr>
-              <a:t>Burndown dei 30 SP: le soste dopo ogni review coincidono con retro e planning</a:t>
+              <a:rPr sz="1400" b="1">
+                <a:solidFill>
+                  <a:srgbClr val="121C46"/>
+                </a:solidFill>
+                <a:latin typeface="Calibri"/>
+              </a:rPr>
+              <a:t>Review al completamento di ogni macro-funzionalità</a:t>
             </a:r>
           </a:p>
         </p:txBody>
       </p:sp>
       <p:graphicFrame>
         <p:nvGraphicFramePr>
-          <p:cNvPr id="23" name="Table 22"/>
+          <p:cNvPr id="26" name="Table 25"/>
           <p:cNvGraphicFramePr>
             <a:graphicFrameLocks noGrp="1"/>
           </p:cNvGraphicFramePr>
           <p:nvPr/>
         </p:nvGraphicFramePr>
         <p:xfrm>
-          <a:off x="5806440" y="4892040"/>
-          <a:ext cx="5989320" cy="1316736"/>
+          <a:off x="411480" y="4526280"/>
+          <a:ext cx="11338560" cy="1536192"/>
         </p:xfrm>
         <a:graphic>
           <a:graphicData uri="http://schemas.openxmlformats.org/drawingml/2006/table">
@@ -7604,18 +7724,18 @@
                 <a:tableStyleId>{5C22544A-7EE6-4342-B048-85BDC9FD1C3A}</a:tableStyleId>
               </a:tblPr>
               <a:tblGrid>
-                <a:gridCol w="640080"/>
-                <a:gridCol w="4709160"/>
-                <a:gridCol w="640080"/>
+                <a:gridCol w="3840480"/>
+                <a:gridCol w="6766560"/>
+                <a:gridCol w="731520"/>
               </a:tblGrid>
-              <a:tr h="329184">
+              <a:tr h="384048">
                 <a:tc>
                   <a:txBody>
                     <a:bodyPr/>
                     <a:lstStyle/>
                     <a:p>
                       <a:pPr>
-                        <a:defRPr sz="1100" b="1">
+                        <a:defRPr sz="1200" b="1">
                           <a:solidFill>
                             <a:srgbClr val="FFFFFF"/>
                           </a:solidFill>
@@ -7623,7 +7743,7 @@
                         </a:defRPr>
                       </a:pPr>
                       <a:r>
-                        <a:t>Sprint</a:t>
+                        <a:t>Macro-funzionalità</a:t>
                       </a:r>
                     </a:p>
                   </a:txBody>
@@ -7639,7 +7759,7 @@
                     <a:lstStyle/>
                     <a:p>
                       <a:pPr>
-                        <a:defRPr sz="1100" b="1">
+                        <a:defRPr sz="1200" b="1">
                           <a:solidFill>
                             <a:srgbClr val="FFFFFF"/>
                           </a:solidFill>
@@ -7647,7 +7767,7 @@
                         </a:defRPr>
                       </a:pPr>
                       <a:r>
-                        <a:t>Obiettivo</a:t>
+                        <a:t>Flusso verificato nella review</a:t>
                       </a:r>
                     </a:p>
                   </a:txBody>
@@ -7663,7 +7783,7 @@
                     <a:lstStyle/>
                     <a:p>
                       <a:pPr>
-                        <a:defRPr sz="1100" b="1">
+                        <a:defRPr sz="1200" b="1">
                           <a:solidFill>
                             <a:srgbClr val="FFFFFF"/>
                           </a:solidFill>
@@ -7682,14 +7802,14 @@
                   </a:tcPr>
                 </a:tc>
               </a:tr>
-              <a:tr h="329184">
+              <a:tr h="384048">
                 <a:tc>
                   <a:txBody>
                     <a:bodyPr/>
                     <a:lstStyle/>
                     <a:p>
                       <a:pPr>
-                        <a:defRPr sz="1100" b="0">
+                        <a:defRPr sz="1200" b="0">
                           <a:solidFill>
                             <a:srgbClr val="1A2033"/>
                           </a:solidFill>
@@ -7697,7 +7817,7 @@
                         </a:defRPr>
                       </a:pPr>
                       <a:r>
-                        <a:t>S1</a:t>
+                        <a:t>MF1 · Organizzazione campionato e accesso</a:t>
                       </a:r>
                     </a:p>
                   </a:txBody>
@@ -7713,7 +7833,7 @@
                     <a:lstStyle/>
                     <a:p>
                       <a:pPr>
-                        <a:defRPr sz="1100" b="0">
+                        <a:defRPr sz="1200" b="0">
                           <a:solidFill>
                             <a:srgbClr val="1A2033"/>
                           </a:solidFill>
@@ -7721,7 +7841,7 @@
                         </a:defRPr>
                       </a:pPr>
                       <a:r>
-                        <a:t>MF1 completa: accesso, campionati, calendario, designazioni</a:t>
+                        <a:t>Login per ruolo, creazione campionato, calendario, designazione arbitri</a:t>
                       </a:r>
                     </a:p>
                   </a:txBody>
@@ -7737,7 +7857,7 @@
                     <a:lstStyle/>
                     <a:p>
                       <a:pPr>
-                        <a:defRPr sz="1100" b="0">
+                        <a:defRPr sz="1200" b="0">
                           <a:solidFill>
                             <a:srgbClr val="1A2033"/>
                           </a:solidFill>
@@ -7756,14 +7876,14 @@
                   </a:tcPr>
                 </a:tc>
               </a:tr>
-              <a:tr h="329184">
+              <a:tr h="384048">
                 <a:tc>
                   <a:txBody>
                     <a:bodyPr/>
                     <a:lstStyle/>
                     <a:p>
                       <a:pPr>
-                        <a:defRPr sz="1100" b="0">
+                        <a:defRPr sz="1200" b="0">
                           <a:solidFill>
                             <a:srgbClr val="1A2033"/>
                           </a:solidFill>
@@ -7771,7 +7891,7 @@
                         </a:defRPr>
                       </a:pPr>
                       <a:r>
-                        <a:t>S2</a:t>
+                        <a:t>MF2 · Gestione squadra e lista gara</a:t>
                       </a:r>
                     </a:p>
                   </a:txBody>
@@ -7787,7 +7907,7 @@
                     <a:lstStyle/>
                     <a:p>
                       <a:pPr>
-                        <a:defRPr sz="1100" b="0">
+                        <a:defRPr sz="1200" b="0">
                           <a:solidFill>
                             <a:srgbClr val="1A2033"/>
                           </a:solidFill>
@@ -7795,7 +7915,7 @@
                         </a:defRPr>
                       </a:pPr>
                       <a:r>
-                        <a:t>MF2 completa + persistenza referto (T3.1)</a:t>
+                        <a:t>Rosa, iscrizione, lista gara con controllo dei liberi</a:t>
                       </a:r>
                     </a:p>
                   </a:txBody>
@@ -7811,7 +7931,7 @@
                     <a:lstStyle/>
                     <a:p>
                       <a:pPr>
-                        <a:defRPr sz="1100" b="0">
+                        <a:defRPr sz="1200" b="0">
                           <a:solidFill>
                             <a:srgbClr val="1A2033"/>
                           </a:solidFill>
@@ -7819,7 +7939,7 @@
                         </a:defRPr>
                       </a:pPr>
                       <a:r>
-                        <a:t>11</a:t>
+                        <a:t>8</a:t>
                       </a:r>
                     </a:p>
                   </a:txBody>
@@ -7830,14 +7950,14 @@
                   </a:tcPr>
                 </a:tc>
               </a:tr>
-              <a:tr h="329184">
+              <a:tr h="384048">
                 <a:tc>
                   <a:txBody>
                     <a:bodyPr/>
                     <a:lstStyle/>
                     <a:p>
                       <a:pPr>
-                        <a:defRPr sz="1100" b="0">
+                        <a:defRPr sz="1200" b="0">
                           <a:solidFill>
                             <a:srgbClr val="1A2033"/>
                           </a:solidFill>
@@ -7845,7 +7965,7 @@
                         </a:defRPr>
                       </a:pPr>
                       <a:r>
-                        <a:t>S3</a:t>
+                        <a:t>MF3 · Referto, omologazione e classifica</a:t>
                       </a:r>
                     </a:p>
                   </a:txBody>
@@ -7861,7 +7981,7 @@
                     <a:lstStyle/>
                     <a:p>
                       <a:pPr>
-                        <a:defRPr sz="1100" b="0">
+                        <a:defRPr sz="1200" b="0">
                           <a:solidFill>
                             <a:srgbClr val="1A2033"/>
                           </a:solidFill>
@@ -7869,7 +7989,7 @@
                         </a:defRPr>
                       </a:pPr>
                       <a:r>
-                        <a:t>Validazione referto, omologa, classifica, UI arbitro</a:t>
+                        <a:t>Referto con firma, omologa, classifica e area giocatore</a:t>
                       </a:r>
                     </a:p>
                   </a:txBody>
@@ -7885,7 +8005,7 @@
                     <a:lstStyle/>
                     <a:p>
                       <a:pPr>
-                        <a:defRPr sz="1100" b="0">
+                        <a:defRPr sz="1200" b="0">
                           <a:solidFill>
                             <a:srgbClr val="1A2033"/>
                           </a:solidFill>
@@ -7893,7 +8013,7 @@
                         </a:defRPr>
                       </a:pPr>
                       <a:r>
-                        <a:t>9</a:t>
+                        <a:t>12</a:t>
                       </a:r>
                     </a:p>
                   </a:txBody>
@@ -8165,7 +8285,7 @@
                 </a:solidFill>
                 <a:latin typeface="Calibri"/>
               </a:rPr>
-              <a:t>Volley League · Nome Cognome · Ingegneria del Software · UniFE · A.A. 2025/26</a:t>
+              <a:t>Volley League · Niccolò Gardellini · Ingegneria del Software · UniFE · A.A. 2025/26</a:t>
             </a:r>
           </a:p>
         </p:txBody>
@@ -8211,7 +8331,7 @@
       </p:sp>
       <p:pic>
         <p:nvPicPr>
-          <p:cNvPr id="9" name="Picture 8" descr="miro_disegno_funzionale.png"/>
+          <p:cNvPr id="9" name="Picture 8" descr="miro_board.png"/>
           <p:cNvPicPr>
             <a:picLocks noChangeAspect="1"/>
           </p:cNvPicPr>
@@ -8225,8 +8345,8 @@
         </p:blipFill>
         <p:spPr>
           <a:xfrm>
-            <a:off x="630936" y="1143000"/>
-            <a:ext cx="10927080" cy="5211377"/>
+            <a:off x="411480" y="1143000"/>
+            <a:ext cx="11338560" cy="4619413"/>
           </a:xfrm>
           <a:prstGeom prst="rect">
             <a:avLst/>
@@ -8238,6 +8358,45 @@
           </a:ln>
         </p:spPr>
       </p:pic>
+      <p:sp>
+        <p:nvSpPr>
+          <p:cNvPr id="10" name="TextBox 9"/>
+          <p:cNvSpPr txBox="1"/>
+          <p:nvPr/>
+        </p:nvSpPr>
+        <p:spPr>
+          <a:xfrm>
+            <a:off x="411480" y="5989320"/>
+            <a:ext cx="11338560" cy="274320"/>
+          </a:xfrm>
+          <a:prstGeom prst="rect">
+            <a:avLst/>
+          </a:prstGeom>
+          <a:noFill/>
+        </p:spPr>
+        <p:txBody>
+          <a:bodyPr wrap="square" anchor="t" lIns="45720" rIns="45720" tIns="27432" bIns="27432">
+            <a:spAutoFit/>
+          </a:bodyPr>
+          <a:lstStyle/>
+          <a:p>
+            <a:pPr algn="ctr">
+              <a:spcAft>
+                <a:spcPts val="400"/>
+              </a:spcAft>
+            </a:pPr>
+            <a:r>
+              <a:rPr sz="1000" b="0">
+                <a:solidFill>
+                  <a:srgbClr val="5A6378"/>
+                </a:solidFill>
+                <a:latin typeface="Calibri"/>
+              </a:rPr>
+              <a:t>Board Miro: miro.com/app/board/uXjVEUGhGFs= · attori a sinistra, le 3 macro-funzionalità con i rispettivi SP e le attività di ciascuna</a:t>
+            </a:r>
+          </a:p>
+        </p:txBody>
+      </p:sp>
     </p:spTree>
   </p:cSld>
   <p:clrMapOvr>
@@ -8495,7 +8654,7 @@
                 </a:solidFill>
                 <a:latin typeface="Calibri"/>
               </a:rPr>
-              <a:t>Volley League · Nome Cognome · Ingegneria del Software · UniFE · A.A. 2025/26</a:t>
+              <a:t>Volley League · Niccolò Gardellini · Ingegneria del Software · UniFE · A.A. 2025/26</a:t>
             </a:r>
           </a:p>
         </p:txBody>
@@ -8541,7 +8700,7 @@
       </p:sp>
       <p:pic>
         <p:nvPicPr>
-          <p:cNvPr id="9" name="Picture 8" descr="trello_board.png"/>
+          <p:cNvPr id="9" name="Picture 8" descr="trello_board_reale.png"/>
           <p:cNvPicPr>
             <a:picLocks noChangeAspect="1"/>
           </p:cNvPicPr>
@@ -8555,8 +8714,8 @@
         </p:blipFill>
         <p:spPr>
           <a:xfrm>
-            <a:off x="411480" y="1143000"/>
-            <a:ext cx="8778240" cy="4186545"/>
+            <a:off x="411480" y="1097280"/>
+            <a:ext cx="11338560" cy="3429223"/>
           </a:xfrm>
           <a:prstGeom prst="rect">
             <a:avLst/>
@@ -8576,8 +8735,8 @@
         </p:nvSpPr>
         <p:spPr>
           <a:xfrm>
-            <a:off x="411480" y="5440680"/>
-            <a:ext cx="2103120" cy="868680"/>
+            <a:off x="411480" y="5257800"/>
+            <a:ext cx="2724912" cy="777240"/>
           </a:xfrm>
           <a:prstGeom prst="roundRect">
             <a:avLst>
@@ -8622,8 +8781,8 @@
         </p:nvSpPr>
         <p:spPr>
           <a:xfrm>
-            <a:off x="548640" y="5486400"/>
-            <a:ext cx="868680" cy="777240"/>
+            <a:off x="548640" y="5285232"/>
+            <a:ext cx="960120" cy="731520"/>
           </a:xfrm>
           <a:prstGeom prst="rect">
             <a:avLst/>
@@ -8661,8 +8820,8 @@
         </p:nvSpPr>
         <p:spPr>
           <a:xfrm>
-            <a:off x="1417320" y="5486400"/>
-            <a:ext cx="1051560" cy="777240"/>
+            <a:off x="1508760" y="5285232"/>
+            <a:ext cx="1554480" cy="731520"/>
           </a:xfrm>
           <a:prstGeom prst="rect">
             <a:avLst/>
@@ -8700,8 +8859,8 @@
         </p:nvSpPr>
         <p:spPr>
           <a:xfrm>
-            <a:off x="2633472" y="5440680"/>
-            <a:ext cx="2103120" cy="868680"/>
+            <a:off x="3273552" y="5257800"/>
+            <a:ext cx="2724912" cy="777240"/>
           </a:xfrm>
           <a:prstGeom prst="roundRect">
             <a:avLst>
@@ -8746,8 +8905,8 @@
         </p:nvSpPr>
         <p:spPr>
           <a:xfrm>
-            <a:off x="2770632" y="5486400"/>
-            <a:ext cx="868680" cy="777240"/>
+            <a:off x="3410712" y="5285232"/>
+            <a:ext cx="960120" cy="731520"/>
           </a:xfrm>
           <a:prstGeom prst="rect">
             <a:avLst/>
@@ -8785,8 +8944,8 @@
         </p:nvSpPr>
         <p:spPr>
           <a:xfrm>
-            <a:off x="3639312" y="5486400"/>
-            <a:ext cx="1051560" cy="777240"/>
+            <a:off x="4370832" y="5285232"/>
+            <a:ext cx="1554480" cy="731520"/>
           </a:xfrm>
           <a:prstGeom prst="rect">
             <a:avLst/>
@@ -8811,7 +8970,7 @@
                 </a:solidFill>
                 <a:latin typeface="Calibri"/>
               </a:rPr>
-              <a:t>stimati e completati</a:t>
+              <a:t>10 + 8 + 12 per macro-funzione</a:t>
             </a:r>
           </a:p>
         </p:txBody>
@@ -8824,8 +8983,8 @@
         </p:nvSpPr>
         <p:spPr>
           <a:xfrm>
-            <a:off x="4855464" y="5440680"/>
-            <a:ext cx="2103120" cy="868680"/>
+            <a:off x="6135624" y="5257800"/>
+            <a:ext cx="2724912" cy="777240"/>
           </a:xfrm>
           <a:prstGeom prst="roundRect">
             <a:avLst>
@@ -8870,8 +9029,8 @@
         </p:nvSpPr>
         <p:spPr>
           <a:xfrm>
-            <a:off x="4992624" y="5486400"/>
-            <a:ext cx="868680" cy="777240"/>
+            <a:off x="6272784" y="5285232"/>
+            <a:ext cx="960120" cy="731520"/>
           </a:xfrm>
           <a:prstGeom prst="rect">
             <a:avLst/>
@@ -8909,8 +9068,8 @@
         </p:nvSpPr>
         <p:spPr>
           <a:xfrm>
-            <a:off x="5861304" y="5486400"/>
-            <a:ext cx="1051560" cy="777240"/>
+            <a:off x="7232904" y="5285232"/>
+            <a:ext cx="1554480" cy="731520"/>
           </a:xfrm>
           <a:prstGeom prst="rect">
             <a:avLst/>
@@ -8935,7 +9094,7 @@
                 </a:solidFill>
                 <a:latin typeface="Calibri"/>
               </a:rPr>
-              <a:t>sprint da 5 giorni</a:t>
+              <a:t>macro-funzionalità</a:t>
             </a:r>
           </a:p>
         </p:txBody>
@@ -8948,8 +9107,8 @@
         </p:nvSpPr>
         <p:spPr>
           <a:xfrm>
-            <a:off x="7077456" y="5440680"/>
-            <a:ext cx="2103120" cy="868680"/>
+            <a:off x="8997696" y="5257800"/>
+            <a:ext cx="2724912" cy="777240"/>
           </a:xfrm>
           <a:prstGeom prst="roundRect">
             <a:avLst>
@@ -8994,8 +9153,8 @@
         </p:nvSpPr>
         <p:spPr>
           <a:xfrm>
-            <a:off x="7214616" y="5486400"/>
-            <a:ext cx="868680" cy="777240"/>
+            <a:off x="9134856" y="5285232"/>
+            <a:ext cx="960120" cy="731520"/>
           </a:xfrm>
           <a:prstGeom prst="rect">
             <a:avLst/>
@@ -9020,7 +9179,7 @@
                 </a:solidFill>
                 <a:latin typeface="Calibri"/>
               </a:rPr>
-              <a:t>100%</a:t>
+              <a:t>3</a:t>
             </a:r>
           </a:p>
         </p:txBody>
@@ -9033,8 +9192,8 @@
         </p:nvSpPr>
         <p:spPr>
           <a:xfrm>
-            <a:off x="8083296" y="5486400"/>
-            <a:ext cx="1051560" cy="777240"/>
+            <a:off x="10094976" y="5285232"/>
+            <a:ext cx="1554480" cy="731520"/>
           </a:xfrm>
           <a:prstGeom prst="rect">
             <a:avLst/>
@@ -9059,7 +9218,7 @@
                 </a:solidFill>
                 <a:latin typeface="Calibri"/>
               </a:rPr>
-              <a:t>card in Done</a:t>
+              <a:t>etichette: FE · BE · DB</a:t>
             </a:r>
           </a:p>
         </p:txBody>
@@ -9072,8 +9231,8 @@
         </p:nvSpPr>
         <p:spPr>
           <a:xfrm>
-            <a:off x="9372600" y="1143000"/>
-            <a:ext cx="2468880" cy="5212080"/>
+            <a:off x="411480" y="6108192"/>
+            <a:ext cx="11338560" cy="274320"/>
           </a:xfrm>
           <a:prstGeom prst="rect">
             <a:avLst/>
@@ -9086,163 +9245,19 @@
           </a:bodyPr>
           <a:lstStyle/>
           <a:p>
-            <a:pPr algn="l">
-              <a:spcAft>
-                <a:spcPts val="100"/>
-              </a:spcAft>
-            </a:pPr>
-            <a:r>
-              <a:rPr sz="1200" b="1">
-                <a:solidFill>
-                  <a:srgbClr val="1F4FD1"/>
-                </a:solidFill>
-                <a:latin typeface="Calibri"/>
-              </a:rPr>
-              <a:t>Liste</a:t>
-            </a:r>
-          </a:p>
-          <a:p>
-            <a:pPr algn="l">
-              <a:spcAft>
-                <a:spcPts val="800"/>
-              </a:spcAft>
-            </a:pPr>
-            <a:r>
-              <a:rPr sz="1100" b="0">
-                <a:solidFill>
-                  <a:srgbClr val="1A2033"/>
-                </a:solidFill>
-                <a:latin typeface="Calibri"/>
-              </a:rPr>
-              <a:t>Backlog → Sprint 1/2/3 → Test &amp; Documentazione</a:t>
-            </a:r>
-          </a:p>
-          <a:p>
-            <a:pPr algn="l">
-              <a:spcAft>
-                <a:spcPts val="100"/>
-              </a:spcAft>
-            </a:pPr>
-            <a:r>
-              <a:rPr sz="1200" b="1">
-                <a:solidFill>
-                  <a:srgbClr val="1F4FD1"/>
-                </a:solidFill>
-                <a:latin typeface="Calibri"/>
-              </a:rPr>
-              <a:t>Etichette</a:t>
-            </a:r>
-          </a:p>
-          <a:p>
-            <a:pPr algn="l">
-              <a:spcAft>
-                <a:spcPts val="800"/>
-              </a:spcAft>
-            </a:pPr>
-            <a:r>
-              <a:rPr sz="1100" b="0">
-                <a:solidFill>
-                  <a:srgbClr val="1A2033"/>
-                </a:solidFill>
-                <a:latin typeface="Calibri"/>
-              </a:rPr>
-              <a:t>FE (verde) · BE (viola) · DB (giallo) per verificare la copertura su tutti i livelli</a:t>
-            </a:r>
-          </a:p>
-          <a:p>
-            <a:pPr algn="l">
-              <a:spcAft>
-                <a:spcPts val="100"/>
-              </a:spcAft>
-            </a:pPr>
-            <a:r>
-              <a:rPr sz="1200" b="1">
-                <a:solidFill>
-                  <a:srgbClr val="1F4FD1"/>
-                </a:solidFill>
-                <a:latin typeface="Calibri"/>
-              </a:rPr>
-              <a:t>Story point</a:t>
-            </a:r>
-          </a:p>
-          <a:p>
-            <a:pPr algn="l">
-              <a:spcAft>
-                <a:spcPts val="800"/>
-              </a:spcAft>
-            </a:pPr>
-            <a:r>
-              <a:rPr sz="1100" b="0">
-                <a:solidFill>
-                  <a:srgbClr val="1A2033"/>
-                </a:solidFill>
-                <a:latin typeface="Calibri"/>
-              </a:rPr>
-              <a:t>Campo SP su ogni card; somma per macro-funzionalità 10 + 8 + 12</a:t>
-            </a:r>
-          </a:p>
-          <a:p>
-            <a:pPr algn="l">
-              <a:spcAft>
-                <a:spcPts val="100"/>
-              </a:spcAft>
-            </a:pPr>
-            <a:r>
-              <a:rPr sz="1200" b="1">
-                <a:solidFill>
-                  <a:srgbClr val="1F4FD1"/>
-                </a:solidFill>
-                <a:latin typeface="Calibri"/>
-              </a:rPr>
-              <a:t>Definition of Done</a:t>
-            </a:r>
-          </a:p>
-          <a:p>
-            <a:pPr algn="l">
-              <a:spcAft>
-                <a:spcPts val="800"/>
-              </a:spcAft>
-            </a:pPr>
-            <a:r>
-              <a:rPr sz="1100" b="0">
-                <a:solidFill>
-                  <a:srgbClr val="1A2033"/>
-                </a:solidFill>
-                <a:latin typeface="Calibri"/>
-              </a:rPr>
-              <a:t>Checklist 'test verdi' e 'verifica UI' spuntata prima di spostare in Done</a:t>
-            </a:r>
-          </a:p>
-          <a:p>
-            <a:pPr algn="l">
-              <a:spcAft>
-                <a:spcPts val="100"/>
-              </a:spcAft>
-            </a:pPr>
-            <a:r>
-              <a:rPr sz="1200" b="1">
-                <a:solidFill>
-                  <a:srgbClr val="1F4FD1"/>
-                </a:solidFill>
-                <a:latin typeface="Calibri"/>
-              </a:rPr>
-              <a:t>Import</a:t>
-            </a:r>
-          </a:p>
-          <a:p>
-            <a:pPr algn="l">
-              <a:spcAft>
-                <a:spcPts val="800"/>
-              </a:spcAft>
-            </a:pPr>
-            <a:r>
-              <a:rPr sz="1100" b="0">
-                <a:solidFill>
-                  <a:srgbClr val="1A2033"/>
-                </a:solidFill>
-                <a:latin typeface="Calibri"/>
-              </a:rPr>
-              <a:t>trello_backlog.csv in relazione_esame/ contiene l'intero backlog</a:t>
+            <a:pPr algn="ctr">
+              <a:spcAft>
+                <a:spcPts val="400"/>
+              </a:spcAft>
+            </a:pPr>
+            <a:r>
+              <a:rPr sz="1000" b="0">
+                <a:solidFill>
+                  <a:srgbClr val="5A6378"/>
+                </a:solidFill>
+                <a:latin typeface="Calibri"/>
+              </a:rPr>
+              <a:t>Board pubblica: trello.com/b/6vciU88a/volley-league · story point indicati nel titolo di ogni card</a:t>
             </a:r>
           </a:p>
         </p:txBody>
@@ -9504,7 +9519,7 @@
                 </a:solidFill>
                 <a:latin typeface="Calibri"/>
               </a:rPr>
-              <a:t>Volley League · Nome Cognome · Ingegneria del Software · UniFE · A.A. 2025/26</a:t>
+              <a:t>Volley League · Niccolò Gardellini · Ingegneria del Software · UniFE · A.A. 2025/26</a:t>
             </a:r>
           </a:p>
         </p:txBody>
@@ -10991,7 +11006,7 @@
                 </a:solidFill>
                 <a:latin typeface="Calibri"/>
               </a:rPr>
-              <a:t>Volley League · Nome Cognome · Ingegneria del Software · UniFE · A.A. 2025/26</a:t>
+              <a:t>Volley League · Niccolò Gardellini · Ingegneria del Software · UniFE · A.A. 2025/26</a:t>
             </a:r>
           </a:p>
         </p:txBody>
@@ -11434,7 +11449,7 @@
                 </a:solidFill>
                 <a:latin typeface="Calibri"/>
               </a:rPr>
-              <a:t>Volley League · Nome Cognome · Ingegneria del Software · UniFE · A.A. 2025/26</a:t>
+              <a:t>Volley League · Niccolò Gardellini · Ingegneria del Software · UniFE · A.A. 2025/26</a:t>
             </a:r>
           </a:p>
         </p:txBody>
@@ -13106,7 +13121,7 @@
                 </a:solidFill>
                 <a:latin typeface="Calibri"/>
               </a:rPr>
-              <a:t>Volley League · Nome Cognome · Ingegneria del Software · UniFE · A.A. 2025/26</a:t>
+              <a:t>Volley League · Niccolò Gardellini · Ingegneria del Software · UniFE · A.A. 2025/26</a:t>
             </a:r>
           </a:p>
         </p:txBody>

</xml_diff>